<commit_message>
Accuracy corrections: scope of model results, schematic lines, coverage labels, remove causal claims
</commit_message>
<xml_diff>
--- a/NYC_Mobility_Strategy.pptx
+++ b/NYC_Mobility_Strategy.pptx
@@ -2972,7 +2972,7 @@
           <a:p>
             <a:r>
               <a:rPr lang="en-US" dirty="0"/>
-              <a:t>Median change minus 0.37 mph (minus 1.0 percent); mean minus 0.88 mph. BQE link 4616229 southbound fell from 42.23 to 21.53 mph during state deck repairs. Data check: 8.4 million readings carried only two status codes, and valid readings had no zero speeds.</a:t>
+              <a:t>Median change minus 0.37 mph (minus 1.0 percent); mean minus 0.88 mph. BQE link 4616229 southbound fell from 42.23 to 21.53 mph while state deck repairs were under way; the speed data alone cannot show the cause. Data check: 8.4 million readings carried only two status codes, and valid readings had no zero speeds.</a:t>
             </a:r>
             <a:endParaRPr lang="en-US" dirty="0"/>
           </a:p>
@@ -4535,7 +4535,7 @@
                 <a:ea typeface="Arial" pitchFamily="34" charset="-122"/>
                 <a:cs typeface="Arial" pitchFamily="34" charset="-120"/>
               </a:rPr>
-              <a:t>On Union Turnpike, faster buses and easier transfers would save 6–12.5 minutes a trip in a model test</a:t>
+              <a:t>From Union Turnpike to Midtown East at 8 a.m., faster buses and easier transfers save 6.2–12.5 minutes in a model test</a:t>
             </a:r>
             <a:endParaRPr lang="en-US" sz="2400" dirty="0"/>
           </a:p>
@@ -9194,7 +9194,7 @@
                   <a:schemeClr val="tx1"/>
                 </a:solidFill>
               </a:rPr>
-              <a:t>42.2 → 21.5 mph (−49%) during deck repairs and lane closures. Not proven to be drivers avoiding the toll.</a:t>
+              <a:t>42.2 → 21.5 mph (−49%). Deck repairs were under way; this data cannot show the cause.</a:t>
             </a:r>
             <a:endParaRPr lang="en-US" sz="1300" dirty="0"/>
           </a:p>
@@ -9742,7 +9742,7 @@
                   <a:schemeClr val="tx1"/>
                 </a:solidFill>
               </a:rPr>
-              <a:t>Start in Eastern Queens, where a model test saves 6–12.5 minutes a trip; follow with the East Bronx and Southeast Queens once their delays are measured.</a:t>
+              <a:t>Start in Eastern Queens, where a model test saves 6.2–12.5 minutes a trip (six Union Turnpike origins to Midtown East, 8 a.m.); follow with the East Bronx and Southeast Queens once their delays are measured.</a:t>
             </a:r>
             <a:endParaRPr lang="en-US" sz="1500" dirty="0"/>
           </a:p>
@@ -13962,7 +13962,7 @@
                 <a:ea typeface="Arial" pitchFamily="34" charset="-122"/>
                 <a:cs typeface="Arial" pitchFamily="34" charset="-120"/>
               </a:rPr>
-              <a:t>Transit trips take about an hour, and walking and waiting take 13–22 minutes of each one</a:t>
+              <a:t>Transit trips take about an hour, and walking and waiting add about 13–22 minutes to each</a:t>
             </a:r>
             <a:endParaRPr lang="en-US" sz="2400" dirty="0"/>
           </a:p>

</xml_diff>